<commit_message>
agregar diagrama de distribución
</commit_message>
<xml_diff>
--- a/_docs_/trim01/01_contextualización/ControlStore_DE.pptx
+++ b/_docs_/trim01/01_contextualización/ControlStore_DE.pptx
@@ -2643,6 +2643,7 @@
                 </a:solidFill>
                 <a:latin typeface="Trebuchet MS"/>
                 <a:cs typeface="Trebuchet MS"/>
+                <a:hlinkClick r:id="rId11"/>
               </a:rPr>
               <a:t>Diagrama</a:t>
             </a:r>
@@ -2653,6 +2654,7 @@
                 </a:solidFill>
                 <a:latin typeface="Trebuchet MS"/>
                 <a:cs typeface="Trebuchet MS"/>
+                <a:hlinkClick r:id="rId11"/>
               </a:rPr>
               <a:t> </a:t>
             </a:r>
@@ -2663,6 +2665,7 @@
                 </a:solidFill>
                 <a:latin typeface="Trebuchet MS"/>
                 <a:cs typeface="Trebuchet MS"/>
+                <a:hlinkClick r:id="rId11"/>
               </a:rPr>
               <a:t>de</a:t>
             </a:r>
@@ -2673,6 +2676,7 @@
                 </a:solidFill>
                 <a:latin typeface="Trebuchet MS"/>
                 <a:cs typeface="Trebuchet MS"/>
+                <a:hlinkClick r:id="rId11"/>
               </a:rPr>
               <a:t> </a:t>
             </a:r>
@@ -2683,6 +2687,7 @@
                 </a:solidFill>
                 <a:latin typeface="Trebuchet MS"/>
                 <a:cs typeface="Trebuchet MS"/>
+                <a:hlinkClick r:id="rId11"/>
               </a:rPr>
               <a:t>procesos </a:t>
             </a:r>
@@ -2693,6 +2698,7 @@
                 </a:solidFill>
                 <a:latin typeface="Trebuchet MS"/>
                 <a:cs typeface="Trebuchet MS"/>
+                <a:hlinkClick r:id="rId12"/>
               </a:rPr>
               <a:t>Análisis</a:t>
             </a:r>
@@ -2703,6 +2709,7 @@
                 </a:solidFill>
                 <a:latin typeface="Trebuchet MS"/>
                 <a:cs typeface="Trebuchet MS"/>
+                <a:hlinkClick r:id="rId12"/>
               </a:rPr>
               <a:t> </a:t>
             </a:r>
@@ -2713,6 +2720,7 @@
                 </a:solidFill>
                 <a:latin typeface="Trebuchet MS"/>
                 <a:cs typeface="Trebuchet MS"/>
+                <a:hlinkClick r:id="rId12"/>
               </a:rPr>
               <a:t>de</a:t>
             </a:r>
@@ -2723,6 +2731,7 @@
                 </a:solidFill>
                 <a:latin typeface="Trebuchet MS"/>
                 <a:cs typeface="Trebuchet MS"/>
+                <a:hlinkClick r:id="rId12"/>
               </a:rPr>
               <a:t> </a:t>
             </a:r>
@@ -2733,6 +2742,7 @@
                 </a:solidFill>
                 <a:latin typeface="Trebuchet MS"/>
                 <a:cs typeface="Trebuchet MS"/>
+                <a:hlinkClick r:id="rId12"/>
               </a:rPr>
               <a:t>necesidades </a:t>
             </a:r>
@@ -2743,6 +2753,7 @@
                 </a:solidFill>
                 <a:latin typeface="Trebuchet MS"/>
                 <a:cs typeface="Trebuchet MS"/>
+                <a:hlinkClick r:id="rId13"/>
               </a:rPr>
               <a:t>Requisitos</a:t>
             </a:r>
@@ -2753,6 +2764,7 @@
                 </a:solidFill>
                 <a:latin typeface="Trebuchet MS"/>
                 <a:cs typeface="Trebuchet MS"/>
+                <a:hlinkClick r:id="rId13"/>
               </a:rPr>
               <a:t> </a:t>
             </a:r>
@@ -2763,6 +2775,7 @@
                 </a:solidFill>
                 <a:latin typeface="Trebuchet MS"/>
                 <a:cs typeface="Trebuchet MS"/>
+                <a:hlinkClick r:id="rId13"/>
               </a:rPr>
               <a:t>IEEE-</a:t>
             </a:r>
@@ -2773,6 +2786,7 @@
                 </a:solidFill>
                 <a:latin typeface="Trebuchet MS"/>
                 <a:cs typeface="Trebuchet MS"/>
+                <a:hlinkClick r:id="rId13"/>
               </a:rPr>
               <a:t>830</a:t>
             </a:r>
@@ -2915,6 +2929,7 @@
                 </a:solidFill>
                 <a:latin typeface="Trebuchet MS"/>
                 <a:cs typeface="Trebuchet MS"/>
+                <a:hlinkClick r:id="rId14"/>
               </a:rPr>
               <a:t>Casos</a:t>
             </a:r>
@@ -2925,6 +2940,7 @@
                 </a:solidFill>
                 <a:latin typeface="Trebuchet MS"/>
                 <a:cs typeface="Trebuchet MS"/>
+                <a:hlinkClick r:id="rId14"/>
               </a:rPr>
               <a:t> </a:t>
             </a:r>
@@ -2935,6 +2951,7 @@
                 </a:solidFill>
                 <a:latin typeface="Trebuchet MS"/>
                 <a:cs typeface="Trebuchet MS"/>
+                <a:hlinkClick r:id="rId14"/>
               </a:rPr>
               <a:t>de</a:t>
             </a:r>
@@ -2945,6 +2962,7 @@
                 </a:solidFill>
                 <a:latin typeface="Trebuchet MS"/>
                 <a:cs typeface="Trebuchet MS"/>
+                <a:hlinkClick r:id="rId14"/>
               </a:rPr>
               <a:t> </a:t>
             </a:r>
@@ -2955,6 +2973,7 @@
                 </a:solidFill>
                 <a:latin typeface="Trebuchet MS"/>
                 <a:cs typeface="Trebuchet MS"/>
+                <a:hlinkClick r:id="rId14"/>
               </a:rPr>
               <a:t>uso </a:t>
             </a:r>
@@ -2965,6 +2984,7 @@
                 </a:solidFill>
                 <a:latin typeface="Trebuchet MS"/>
                 <a:cs typeface="Trebuchet MS"/>
+                <a:hlinkClick r:id="rId14"/>
               </a:rPr>
               <a:t>(UML) </a:t>
             </a:r>
@@ -2975,6 +2995,7 @@
                 </a:solidFill>
                 <a:latin typeface="Trebuchet MS"/>
                 <a:cs typeface="Trebuchet MS"/>
+                <a:hlinkClick r:id="rId15"/>
               </a:rPr>
               <a:t>Mockups</a:t>
             </a:r>
@@ -2985,6 +3006,7 @@
                 </a:solidFill>
                 <a:latin typeface="Trebuchet MS"/>
                 <a:cs typeface="Trebuchet MS"/>
+                <a:hlinkClick r:id="rId15"/>
               </a:rPr>
               <a:t> </a:t>
             </a:r>
@@ -2995,6 +3017,7 @@
                 </a:solidFill>
                 <a:latin typeface="Trebuchet MS"/>
                 <a:cs typeface="Trebuchet MS"/>
+                <a:hlinkClick r:id="rId15"/>
               </a:rPr>
               <a:t>en</a:t>
             </a:r>
@@ -3005,6 +3028,7 @@
                 </a:solidFill>
                 <a:latin typeface="Trebuchet MS"/>
                 <a:cs typeface="Trebuchet MS"/>
+                <a:hlinkClick r:id="rId15"/>
               </a:rPr>
               <a:t> </a:t>
             </a:r>
@@ -3015,6 +3039,7 @@
                 </a:solidFill>
                 <a:latin typeface="Trebuchet MS"/>
                 <a:cs typeface="Trebuchet MS"/>
+                <a:hlinkClick r:id="rId15"/>
               </a:rPr>
               <a:t>Figma </a:t>
             </a:r>
@@ -3025,6 +3050,7 @@
                 </a:solidFill>
                 <a:latin typeface="Trebuchet MS"/>
                 <a:cs typeface="Trebuchet MS"/>
+                <a:hlinkClick r:id="rId16"/>
               </a:rPr>
               <a:t>Cronograma</a:t>
             </a:r>
@@ -3035,6 +3061,7 @@
                 </a:solidFill>
                 <a:latin typeface="Trebuchet MS"/>
                 <a:cs typeface="Trebuchet MS"/>
+                <a:hlinkClick r:id="rId16"/>
               </a:rPr>
               <a:t> </a:t>
             </a:r>
@@ -3045,6 +3072,7 @@
                 </a:solidFill>
                 <a:latin typeface="Trebuchet MS"/>
                 <a:cs typeface="Trebuchet MS"/>
+                <a:hlinkClick r:id="rId16"/>
               </a:rPr>
               <a:t>y</a:t>
             </a:r>
@@ -3055,6 +3083,7 @@
                 </a:solidFill>
                 <a:latin typeface="Trebuchet MS"/>
                 <a:cs typeface="Trebuchet MS"/>
+                <a:hlinkClick r:id="rId16"/>
               </a:rPr>
               <a:t> </a:t>
             </a:r>
@@ -3065,6 +3094,7 @@
                 </a:solidFill>
                 <a:latin typeface="Trebuchet MS"/>
                 <a:cs typeface="Trebuchet MS"/>
+                <a:hlinkClick r:id="rId16"/>
               </a:rPr>
               <a:t>costos </a:t>
             </a:r>

</xml_diff>